<commit_message>
Organize project and Github upload 7-16-2026
</commit_message>
<xml_diff>
--- a/Figures/Figure1.pptx
+++ b/Figures/Figure1.pptx
@@ -3158,7 +3158,7 @@
           <p:spPr>
             <a:xfrm>
               <a:off x="1691481" y="1038225"/>
-              <a:ext cx="7315199" cy="5486400"/>
+              <a:ext cx="7315200" cy="5486400"/>
             </a:xfrm>
             <a:prstGeom prst="rect">
               <a:avLst/>
@@ -3192,8 +3192,8 @@
           </p:nvSpPr>
           <p:spPr>
             <a:xfrm>
-              <a:off x="3673851" y="1107814"/>
-              <a:ext cx="5263241" cy="4786991"/>
+              <a:off x="3678613" y="1107814"/>
+              <a:ext cx="5258478" cy="4777466"/>
             </a:xfrm>
             <a:prstGeom prst="rect">
               <a:avLst/>
@@ -3218,18 +3218,18 @@
           </p:nvSpPr>
           <p:spPr>
             <a:xfrm>
-              <a:off x="6301336" y="5210949"/>
-              <a:ext cx="1261435" cy="0"/>
+              <a:off x="6311393" y="5202785"/>
+              <a:ext cx="1262829" cy="0"/>
             </a:xfrm>
             <a:custGeom>
               <a:avLst/>
               <a:pathLst>
-                <a:path w="1261435" h="0">
+                <a:path w="1262829" h="0">
                   <a:moveTo>
                     <a:pt x="0" y="0"/>
                   </a:moveTo>
                   <a:lnTo>
-                    <a:pt x="1261435" y="0"/>
+                    <a:pt x="1262829" y="0"/>
                   </a:lnTo>
                 </a:path>
               </a:pathLst>
@@ -3258,15 +3258,15 @@
           </p:nvSpPr>
           <p:spPr>
             <a:xfrm>
-              <a:off x="4619423" y="5210949"/>
-              <a:ext cx="560637" cy="0"/>
+              <a:off x="4627620" y="5202785"/>
+              <a:ext cx="561257" cy="0"/>
             </a:xfrm>
             <a:custGeom>
               <a:avLst/>
               <a:pathLst>
-                <a:path w="560637" h="0">
+                <a:path w="561257" h="0">
                   <a:moveTo>
-                    <a:pt x="560637" y="0"/>
+                    <a:pt x="561257" y="0"/>
                   </a:moveTo>
                   <a:lnTo>
                     <a:pt x="0" y="0"/>
@@ -3298,24 +3298,24 @@
           </p:nvSpPr>
           <p:spPr>
             <a:xfrm>
-              <a:off x="5180060" y="4783539"/>
-              <a:ext cx="1121275" cy="854819"/>
+              <a:off x="5188878" y="4776225"/>
+              <a:ext cx="1122514" cy="853119"/>
             </a:xfrm>
             <a:custGeom>
               <a:avLst/>
               <a:pathLst>
-                <a:path w="1121275" h="854819">
+                <a:path w="1122514" h="853119">
                   <a:moveTo>
-                    <a:pt x="1121275" y="854819"/>
+                    <a:pt x="1122514" y="853119"/>
                   </a:moveTo>
                   <a:lnTo>
-                    <a:pt x="0" y="854819"/>
+                    <a:pt x="0" y="853119"/>
                   </a:lnTo>
                   <a:lnTo>
                     <a:pt x="0" y="0"/>
                   </a:lnTo>
                   <a:lnTo>
-                    <a:pt x="1121275" y="0"/>
+                    <a:pt x="1122514" y="0"/>
                   </a:lnTo>
                   <a:close/>
                 </a:path>
@@ -3345,15 +3345,15 @@
           </p:nvSpPr>
           <p:spPr>
             <a:xfrm>
-              <a:off x="5740698" y="4783539"/>
-              <a:ext cx="0" cy="854819"/>
+              <a:off x="5750135" y="4776225"/>
+              <a:ext cx="0" cy="853119"/>
             </a:xfrm>
             <a:custGeom>
               <a:avLst/>
               <a:pathLst>
-                <a:path w="0" h="854819">
+                <a:path w="0" h="853119">
                   <a:moveTo>
-                    <a:pt x="0" y="854819"/>
+                    <a:pt x="0" y="853119"/>
                   </a:moveTo>
                   <a:lnTo>
                     <a:pt x="0" y="0"/>
@@ -3385,7 +3385,7 @@
           </p:nvSpPr>
           <p:spPr>
             <a:xfrm>
-              <a:off x="3893799" y="4046363"/>
+              <a:off x="3901222" y="4040467"/>
               <a:ext cx="49651" cy="49651"/>
             </a:xfrm>
             <a:prstGeom prst="ellipse">
@@ -3420,18 +3420,18 @@
           </p:nvSpPr>
           <p:spPr>
             <a:xfrm>
-              <a:off x="6161177" y="4071189"/>
-              <a:ext cx="840956" cy="0"/>
+              <a:off x="6171078" y="4065293"/>
+              <a:ext cx="841886" cy="0"/>
             </a:xfrm>
             <a:custGeom>
               <a:avLst/>
               <a:pathLst>
-                <a:path w="840956" h="0">
+                <a:path w="841886" h="0">
                   <a:moveTo>
                     <a:pt x="0" y="0"/>
                   </a:moveTo>
                   <a:lnTo>
-                    <a:pt x="840956" y="0"/>
+                    <a:pt x="841886" y="0"/>
                   </a:lnTo>
                 </a:path>
               </a:pathLst>
@@ -3460,15 +3460,15 @@
           </p:nvSpPr>
           <p:spPr>
             <a:xfrm>
-              <a:off x="5039901" y="4071189"/>
-              <a:ext cx="455518" cy="0"/>
+              <a:off x="5048563" y="4065293"/>
+              <a:ext cx="456021" cy="0"/>
             </a:xfrm>
             <a:custGeom>
               <a:avLst/>
               <a:pathLst>
-                <a:path w="455518" h="0">
+                <a:path w="456021" h="0">
                   <a:moveTo>
-                    <a:pt x="455518" y="0"/>
+                    <a:pt x="456021" y="0"/>
                   </a:moveTo>
                   <a:lnTo>
                     <a:pt x="0" y="0"/>
@@ -3500,24 +3500,24 @@
           </p:nvSpPr>
           <p:spPr>
             <a:xfrm>
-              <a:off x="5495419" y="3643779"/>
-              <a:ext cx="665757" cy="854819"/>
+              <a:off x="5504585" y="3638733"/>
+              <a:ext cx="666493" cy="853119"/>
             </a:xfrm>
             <a:custGeom>
               <a:avLst/>
               <a:pathLst>
-                <a:path w="665757" h="854819">
+                <a:path w="666493" h="853119">
                   <a:moveTo>
-                    <a:pt x="665757" y="854819"/>
+                    <a:pt x="666493" y="853119"/>
                   </a:moveTo>
                   <a:lnTo>
-                    <a:pt x="0" y="854819"/>
+                    <a:pt x="0" y="853119"/>
                   </a:lnTo>
                   <a:lnTo>
                     <a:pt x="0" y="0"/>
                   </a:lnTo>
                   <a:lnTo>
-                    <a:pt x="665757" y="0"/>
+                    <a:pt x="666493" y="0"/>
                   </a:lnTo>
                   <a:close/>
                 </a:path>
@@ -3547,15 +3547,15 @@
           </p:nvSpPr>
           <p:spPr>
             <a:xfrm>
-              <a:off x="6021017" y="3643779"/>
-              <a:ext cx="0" cy="854819"/>
+              <a:off x="6030764" y="3638733"/>
+              <a:ext cx="0" cy="853119"/>
             </a:xfrm>
             <a:custGeom>
               <a:avLst/>
               <a:pathLst>
-                <a:path w="0" h="854819">
+                <a:path w="0" h="853119">
                   <a:moveTo>
-                    <a:pt x="0" y="854819"/>
+                    <a:pt x="0" y="853119"/>
                   </a:moveTo>
                   <a:lnTo>
                     <a:pt x="0" y="0"/>
@@ -3587,18 +3587,18 @@
           </p:nvSpPr>
           <p:spPr>
             <a:xfrm>
-              <a:off x="6651735" y="2931429"/>
-              <a:ext cx="911036" cy="0"/>
+              <a:off x="6662179" y="2927801"/>
+              <a:ext cx="912043" cy="0"/>
             </a:xfrm>
             <a:custGeom>
               <a:avLst/>
               <a:pathLst>
-                <a:path w="911036" h="0">
+                <a:path w="912043" h="0">
                   <a:moveTo>
                     <a:pt x="0" y="0"/>
                   </a:moveTo>
                   <a:lnTo>
-                    <a:pt x="911036" y="0"/>
+                    <a:pt x="912043" y="0"/>
                   </a:lnTo>
                 </a:path>
               </a:pathLst>
@@ -3627,15 +3627,15 @@
           </p:nvSpPr>
           <p:spPr>
             <a:xfrm>
-              <a:off x="4058785" y="2931429"/>
-              <a:ext cx="1226395" cy="0"/>
+              <a:off x="4066363" y="2927801"/>
+              <a:ext cx="1227750" cy="0"/>
             </a:xfrm>
             <a:custGeom>
               <a:avLst/>
               <a:pathLst>
-                <a:path w="1226395" h="0">
+                <a:path w="1227750" h="0">
                   <a:moveTo>
-                    <a:pt x="1226395" y="0"/>
+                    <a:pt x="1227750" y="0"/>
                   </a:moveTo>
                   <a:lnTo>
                     <a:pt x="0" y="0"/>
@@ -3667,24 +3667,24 @@
           </p:nvSpPr>
           <p:spPr>
             <a:xfrm>
-              <a:off x="5285180" y="2504019"/>
-              <a:ext cx="1366554" cy="854819"/>
+              <a:off x="5294113" y="2501241"/>
+              <a:ext cx="1368065" cy="853119"/>
             </a:xfrm>
             <a:custGeom>
               <a:avLst/>
               <a:pathLst>
-                <a:path w="1366554" h="854819">
+                <a:path w="1368065" h="853119">
                   <a:moveTo>
-                    <a:pt x="1366554" y="854819"/>
+                    <a:pt x="1368065" y="853119"/>
                   </a:moveTo>
                   <a:lnTo>
-                    <a:pt x="0" y="854819"/>
+                    <a:pt x="0" y="853119"/>
                   </a:lnTo>
                   <a:lnTo>
                     <a:pt x="0" y="0"/>
                   </a:lnTo>
                   <a:lnTo>
-                    <a:pt x="1366554" y="0"/>
+                    <a:pt x="1368065" y="0"/>
                   </a:lnTo>
                   <a:close/>
                 </a:path>
@@ -3714,15 +3714,15 @@
           </p:nvSpPr>
           <p:spPr>
             <a:xfrm>
-              <a:off x="5740698" y="2504019"/>
-              <a:ext cx="0" cy="854819"/>
+              <a:off x="5750135" y="2501241"/>
+              <a:ext cx="0" cy="853119"/>
             </a:xfrm>
             <a:custGeom>
               <a:avLst/>
               <a:pathLst>
-                <a:path w="0" h="854819">
+                <a:path w="0" h="853119">
                   <a:moveTo>
-                    <a:pt x="0" y="854819"/>
+                    <a:pt x="0" y="853119"/>
                   </a:moveTo>
                   <a:lnTo>
                     <a:pt x="0" y="0"/>
@@ -3754,7 +3754,7 @@
           </p:nvSpPr>
           <p:spPr>
             <a:xfrm>
-              <a:off x="8659221" y="1766844"/>
+              <a:off x="8671911" y="1765483"/>
               <a:ext cx="49651" cy="49651"/>
             </a:xfrm>
             <a:prstGeom prst="ellipse">
@@ -3789,18 +3789,18 @@
           </p:nvSpPr>
           <p:spPr>
             <a:xfrm>
-              <a:off x="6546615" y="1791669"/>
-              <a:ext cx="1436634" cy="0"/>
+              <a:off x="6556943" y="1790309"/>
+              <a:ext cx="1438222" cy="0"/>
             </a:xfrm>
             <a:custGeom>
               <a:avLst/>
               <a:pathLst>
-                <a:path w="1436634" h="0">
+                <a:path w="1438222" h="0">
                   <a:moveTo>
                     <a:pt x="0" y="0"/>
                   </a:moveTo>
                   <a:lnTo>
-                    <a:pt x="1436634" y="0"/>
+                    <a:pt x="1438222" y="0"/>
                   </a:lnTo>
                 </a:path>
               </a:pathLst>
@@ -3829,15 +3829,15 @@
           </p:nvSpPr>
           <p:spPr>
             <a:xfrm>
-              <a:off x="4899741" y="1791669"/>
-              <a:ext cx="245279" cy="0"/>
+              <a:off x="4908249" y="1790309"/>
+              <a:ext cx="245550" cy="0"/>
             </a:xfrm>
             <a:custGeom>
               <a:avLst/>
               <a:pathLst>
-                <a:path w="245279" h="0">
+                <a:path w="245550" h="0">
                   <a:moveTo>
-                    <a:pt x="245279" y="0"/>
+                    <a:pt x="245550" y="0"/>
                   </a:moveTo>
                   <a:lnTo>
                     <a:pt x="0" y="0"/>
@@ -3869,24 +3869,24 @@
           </p:nvSpPr>
           <p:spPr>
             <a:xfrm>
-              <a:off x="5145021" y="1364260"/>
-              <a:ext cx="1401594" cy="854819"/>
+              <a:off x="5153799" y="1363749"/>
+              <a:ext cx="1403143" cy="853119"/>
             </a:xfrm>
             <a:custGeom>
               <a:avLst/>
               <a:pathLst>
-                <a:path w="1401594" h="854819">
+                <a:path w="1403143" h="853119">
                   <a:moveTo>
-                    <a:pt x="1401594" y="854819"/>
+                    <a:pt x="1403143" y="853119"/>
                   </a:moveTo>
                   <a:lnTo>
-                    <a:pt x="0" y="854819"/>
+                    <a:pt x="0" y="853119"/>
                   </a:lnTo>
                   <a:lnTo>
                     <a:pt x="0" y="0"/>
                   </a:lnTo>
                   <a:lnTo>
-                    <a:pt x="1401594" y="0"/>
+                    <a:pt x="1403143" y="0"/>
                   </a:lnTo>
                   <a:close/>
                 </a:path>
@@ -3916,15 +3916,15 @@
           </p:nvSpPr>
           <p:spPr>
             <a:xfrm>
-              <a:off x="5740698" y="1364260"/>
-              <a:ext cx="0" cy="854819"/>
+              <a:off x="5750135" y="1363749"/>
+              <a:ext cx="0" cy="853119"/>
             </a:xfrm>
             <a:custGeom>
               <a:avLst/>
               <a:pathLst>
-                <a:path w="0" h="854819">
+                <a:path w="0" h="853119">
                   <a:moveTo>
-                    <a:pt x="0" y="854819"/>
+                    <a:pt x="0" y="853119"/>
                   </a:moveTo>
                   <a:lnTo>
                     <a:pt x="0" y="0"/>
@@ -3956,7 +3956,7 @@
           </p:nvSpPr>
           <p:spPr>
             <a:xfrm>
-              <a:off x="4008105" y="3097788"/>
+              <a:off x="4017191" y="3187857"/>
               <a:ext cx="117404" cy="117404"/>
             </a:xfrm>
             <a:prstGeom prst="ellipse">
@@ -3991,7 +3991,7 @@
           </p:nvSpPr>
           <p:spPr>
             <a:xfrm>
-              <a:off x="4848201" y="2578396"/>
+              <a:off x="4861982" y="3270988"/>
               <a:ext cx="117404" cy="117404"/>
             </a:xfrm>
             <a:prstGeom prst="ellipse">
@@ -4026,7 +4026,7 @@
           </p:nvSpPr>
           <p:spPr>
             <a:xfrm>
-              <a:off x="4992035" y="2924917"/>
+              <a:off x="4976861" y="2619060"/>
               <a:ext cx="117404" cy="117404"/>
             </a:xfrm>
             <a:prstGeom prst="ellipse">
@@ -4061,7 +4061,7 @@
           </p:nvSpPr>
           <p:spPr>
             <a:xfrm>
-              <a:off x="5129801" y="3079615"/>
+              <a:off x="5126632" y="2584118"/>
               <a:ext cx="117404" cy="117404"/>
             </a:xfrm>
             <a:prstGeom prst="ellipse">
@@ -4096,7 +4096,7 @@
           </p:nvSpPr>
           <p:spPr>
             <a:xfrm>
-              <a:off x="5253086" y="2655689"/>
+              <a:off x="5269698" y="2579369"/>
               <a:ext cx="117404" cy="117404"/>
             </a:xfrm>
             <a:prstGeom prst="ellipse">
@@ -4131,7 +4131,7 @@
           </p:nvSpPr>
           <p:spPr>
             <a:xfrm>
-              <a:off x="5255991" y="2813366"/>
+              <a:off x="5274943" y="2583713"/>
               <a:ext cx="117404" cy="117404"/>
             </a:xfrm>
             <a:prstGeom prst="ellipse">
@@ -4166,7 +4166,7 @@
           </p:nvSpPr>
           <p:spPr>
             <a:xfrm>
-              <a:off x="5409772" y="2617181"/>
+              <a:off x="5401361" y="2889868"/>
               <a:ext cx="117404" cy="117404"/>
             </a:xfrm>
             <a:prstGeom prst="ellipse">
@@ -4201,7 +4201,7 @@
           </p:nvSpPr>
           <p:spPr>
             <a:xfrm>
-              <a:off x="5553828" y="2516252"/>
+              <a:off x="5553041" y="2905242"/>
               <a:ext cx="117404" cy="117404"/>
             </a:xfrm>
             <a:prstGeom prst="ellipse">
@@ -4236,7 +4236,7 @@
           </p:nvSpPr>
           <p:spPr>
             <a:xfrm>
-              <a:off x="5825304" y="2844270"/>
+              <a:off x="5836495" y="2561729"/>
               <a:ext cx="117404" cy="117404"/>
             </a:xfrm>
             <a:prstGeom prst="ellipse">
@@ -4271,7 +4271,7 @@
           </p:nvSpPr>
           <p:spPr>
             <a:xfrm>
-              <a:off x="6094501" y="2478422"/>
+              <a:off x="6111624" y="2934589"/>
               <a:ext cx="117404" cy="117404"/>
             </a:xfrm>
             <a:prstGeom prst="ellipse">
@@ -4306,7 +4306,7 @@
           </p:nvSpPr>
           <p:spPr>
             <a:xfrm>
-              <a:off x="6382455" y="3274929"/>
+              <a:off x="6381613" y="2838962"/>
               <a:ext cx="117404" cy="117404"/>
             </a:xfrm>
             <a:prstGeom prst="ellipse">
@@ -4341,7 +4341,7 @@
           </p:nvSpPr>
           <p:spPr>
             <a:xfrm>
-              <a:off x="6517286" y="2421010"/>
+              <a:off x="6541625" y="2809268"/>
               <a:ext cx="117404" cy="117404"/>
             </a:xfrm>
             <a:prstGeom prst="ellipse">
@@ -4376,7 +4376,7 @@
           </p:nvSpPr>
           <p:spPr>
             <a:xfrm>
-              <a:off x="6805175" y="3164816"/>
+              <a:off x="6802678" y="2872216"/>
               <a:ext cx="117404" cy="117404"/>
             </a:xfrm>
             <a:prstGeom prst="ellipse">
@@ -4411,7 +4411,7 @@
           </p:nvSpPr>
           <p:spPr>
             <a:xfrm>
-              <a:off x="6954439" y="2439067"/>
+              <a:off x="6965086" y="2932758"/>
               <a:ext cx="117404" cy="117404"/>
             </a:xfrm>
             <a:prstGeom prst="ellipse">
@@ -4446,7 +4446,7 @@
           </p:nvSpPr>
           <p:spPr>
             <a:xfrm>
-              <a:off x="6948824" y="2634173"/>
+              <a:off x="6940631" y="3068529"/>
               <a:ext cx="117404" cy="117404"/>
             </a:xfrm>
             <a:prstGeom prst="ellipse">
@@ -4481,7 +4481,7 @@
           </p:nvSpPr>
           <p:spPr>
             <a:xfrm>
-              <a:off x="7509786" y="3059507"/>
+              <a:off x="7528745" y="3186841"/>
               <a:ext cx="117404" cy="117404"/>
             </a:xfrm>
             <a:prstGeom prst="ellipse">
@@ -4516,7 +4516,7 @@
           </p:nvSpPr>
           <p:spPr>
             <a:xfrm>
-              <a:off x="4832837" y="1411541"/>
+              <a:off x="4856175" y="2140858"/>
               <a:ext cx="117404" cy="117404"/>
             </a:xfrm>
             <a:prstGeom prst="ellipse">
@@ -4551,7 +4551,7 @@
           </p:nvSpPr>
           <p:spPr>
             <a:xfrm>
-              <a:off x="4993708" y="2094634"/>
+              <a:off x="4979277" y="1557867"/>
               <a:ext cx="117404" cy="117404"/>
             </a:xfrm>
             <a:prstGeom prst="ellipse">
@@ -4586,7 +4586,7 @@
           </p:nvSpPr>
           <p:spPr>
             <a:xfrm>
-              <a:off x="4972924" y="2125776"/>
+              <a:off x="4984400" y="1509819"/>
               <a:ext cx="117404" cy="117404"/>
             </a:xfrm>
             <a:prstGeom prst="ellipse">
@@ -4621,7 +4621,7 @@
           </p:nvSpPr>
           <p:spPr>
             <a:xfrm>
-              <a:off x="4976753" y="1891350"/>
+              <a:off x="4988318" y="2103161"/>
               <a:ext cx="117404" cy="117404"/>
             </a:xfrm>
             <a:prstGeom prst="ellipse">
@@ -4656,7 +4656,7 @@
           </p:nvSpPr>
           <p:spPr>
             <a:xfrm>
-              <a:off x="4988064" y="1888496"/>
+              <a:off x="5002995" y="1513667"/>
               <a:ext cx="117404" cy="117404"/>
             </a:xfrm>
             <a:prstGeom prst="ellipse">
@@ -4691,7 +4691,7 @@
           </p:nvSpPr>
           <p:spPr>
             <a:xfrm>
-              <a:off x="5116046" y="1996690"/>
+              <a:off x="5124498" y="1695569"/>
               <a:ext cx="117404" cy="117404"/>
             </a:xfrm>
             <a:prstGeom prst="ellipse">
@@ -4726,7 +4726,7 @@
           </p:nvSpPr>
           <p:spPr>
             <a:xfrm>
-              <a:off x="5271258" y="1652058"/>
+              <a:off x="5279365" y="1410323"/>
               <a:ext cx="117404" cy="117404"/>
             </a:xfrm>
             <a:prstGeom prst="ellipse">
@@ -4761,7 +4761,7 @@
           </p:nvSpPr>
           <p:spPr>
             <a:xfrm>
-              <a:off x="5257561" y="1570308"/>
+              <a:off x="5261074" y="1379796"/>
               <a:ext cx="117404" cy="117404"/>
             </a:xfrm>
             <a:prstGeom prst="ellipse">
@@ -4796,7 +4796,7 @@
           </p:nvSpPr>
           <p:spPr>
             <a:xfrm>
-              <a:off x="5546026" y="1322072"/>
+              <a:off x="5537329" y="1470848"/>
               <a:ext cx="117404" cy="117404"/>
             </a:xfrm>
             <a:prstGeom prst="ellipse">
@@ -4831,7 +4831,7 @@
           </p:nvSpPr>
           <p:spPr>
             <a:xfrm>
-              <a:off x="5679273" y="1582743"/>
+              <a:off x="5681137" y="1821848"/>
               <a:ext cx="117404" cy="117404"/>
             </a:xfrm>
             <a:prstGeom prst="ellipse">
@@ -4866,7 +4866,7 @@
           </p:nvSpPr>
           <p:spPr>
             <a:xfrm>
-              <a:off x="5693611" y="1970404"/>
+              <a:off x="5683133" y="1781743"/>
               <a:ext cx="117404" cy="117404"/>
             </a:xfrm>
             <a:prstGeom prst="ellipse">
@@ -4901,7 +4901,7 @@
           </p:nvSpPr>
           <p:spPr>
             <a:xfrm>
-              <a:off x="5951922" y="1626217"/>
+              <a:off x="5983441" y="1501853"/>
               <a:ext cx="117404" cy="117404"/>
             </a:xfrm>
             <a:prstGeom prst="ellipse">
@@ -4936,7 +4936,7 @@
           </p:nvSpPr>
           <p:spPr>
             <a:xfrm>
-              <a:off x="6388323" y="1650817"/>
+              <a:off x="6386075" y="1455012"/>
               <a:ext cx="117404" cy="117404"/>
             </a:xfrm>
             <a:prstGeom prst="ellipse">
@@ -4971,7 +4971,7 @@
           </p:nvSpPr>
           <p:spPr>
             <a:xfrm>
-              <a:off x="6372537" y="1721404"/>
+              <a:off x="6393731" y="1313874"/>
               <a:ext cx="117404" cy="117404"/>
             </a:xfrm>
             <a:prstGeom prst="ellipse">
@@ -5006,7 +5006,7 @@
           </p:nvSpPr>
           <p:spPr>
             <a:xfrm>
-              <a:off x="6382989" y="2089567"/>
+              <a:off x="6403933" y="1627232"/>
               <a:ext cx="117404" cy="117404"/>
             </a:xfrm>
             <a:prstGeom prst="ellipse">
@@ -5041,7 +5041,7 @@
           </p:nvSpPr>
           <p:spPr>
             <a:xfrm>
-              <a:off x="6800902" y="2083278"/>
+              <a:off x="6827845" y="1642752"/>
               <a:ext cx="117404" cy="117404"/>
             </a:xfrm>
             <a:prstGeom prst="ellipse">
@@ -5076,7 +5076,7 @@
           </p:nvSpPr>
           <p:spPr>
             <a:xfrm>
-              <a:off x="6951995" y="1390375"/>
+              <a:off x="6960902" y="2114340"/>
               <a:ext cx="117404" cy="117404"/>
             </a:xfrm>
             <a:prstGeom prst="ellipse">
@@ -5111,7 +5111,7 @@
           </p:nvSpPr>
           <p:spPr>
             <a:xfrm>
-              <a:off x="7232739" y="1895817"/>
+              <a:off x="7236445" y="2117074"/>
               <a:ext cx="117404" cy="117404"/>
             </a:xfrm>
             <a:prstGeom prst="ellipse">
@@ -5146,7 +5146,7 @@
           </p:nvSpPr>
           <p:spPr>
             <a:xfrm>
-              <a:off x="7918516" y="2101814"/>
+              <a:off x="7946228" y="1733864"/>
               <a:ext cx="117404" cy="117404"/>
             </a:xfrm>
             <a:prstGeom prst="ellipse">
@@ -5181,7 +5181,7 @@
           </p:nvSpPr>
           <p:spPr>
             <a:xfrm>
-              <a:off x="8639151" y="1567082"/>
+              <a:off x="8639368" y="1996449"/>
               <a:ext cx="117404" cy="117404"/>
             </a:xfrm>
             <a:prstGeom prst="ellipse">
@@ -5216,7 +5216,7 @@
           </p:nvSpPr>
           <p:spPr>
             <a:xfrm>
-              <a:off x="3854386" y="3845395"/>
+              <a:off x="3858932" y="3618763"/>
               <a:ext cx="117404" cy="117404"/>
             </a:xfrm>
             <a:prstGeom prst="ellipse">
@@ -5251,7 +5251,7 @@
           </p:nvSpPr>
           <p:spPr>
             <a:xfrm>
-              <a:off x="4993689" y="3844249"/>
+              <a:off x="4992950" y="3904661"/>
               <a:ext cx="117404" cy="117404"/>
             </a:xfrm>
             <a:prstGeom prst="ellipse">
@@ -5286,7 +5286,7 @@
           </p:nvSpPr>
           <p:spPr>
             <a:xfrm>
-              <a:off x="5414268" y="3566414"/>
+              <a:off x="5411029" y="4154684"/>
               <a:ext cx="117404" cy="117404"/>
             </a:xfrm>
             <a:prstGeom prst="ellipse">
@@ -5321,7 +5321,7 @@
           </p:nvSpPr>
           <p:spPr>
             <a:xfrm>
-              <a:off x="5536843" y="3898663"/>
+              <a:off x="5562369" y="3564222"/>
               <a:ext cx="117404" cy="117404"/>
             </a:xfrm>
             <a:prstGeom prst="ellipse">
@@ -5356,7 +5356,7 @@
           </p:nvSpPr>
           <p:spPr>
             <a:xfrm>
-              <a:off x="5958877" y="3885421"/>
+              <a:off x="5959121" y="4238538"/>
               <a:ext cx="117404" cy="117404"/>
             </a:xfrm>
             <a:prstGeom prst="ellipse">
@@ -5391,7 +5391,7 @@
           </p:nvSpPr>
           <p:spPr>
             <a:xfrm>
-              <a:off x="5966784" y="4260789"/>
+              <a:off x="5969017" y="3796075"/>
               <a:ext cx="117404" cy="117404"/>
             </a:xfrm>
             <a:prstGeom prst="ellipse">
@@ -5426,7 +5426,7 @@
           </p:nvSpPr>
           <p:spPr>
             <a:xfrm>
-              <a:off x="6108547" y="3619735"/>
+              <a:off x="6118005" y="4373788"/>
               <a:ext cx="117404" cy="117404"/>
             </a:xfrm>
             <a:prstGeom prst="ellipse">
@@ -5461,7 +5461,7 @@
           </p:nvSpPr>
           <p:spPr>
             <a:xfrm>
-              <a:off x="6095428" y="4172914"/>
+              <a:off x="6106509" y="3598941"/>
               <a:ext cx="117404" cy="117404"/>
             </a:xfrm>
             <a:prstGeom prst="ellipse">
@@ -5496,7 +5496,7 @@
           </p:nvSpPr>
           <p:spPr>
             <a:xfrm>
-              <a:off x="6656429" y="3730560"/>
+              <a:off x="6674510" y="4356160"/>
               <a:ext cx="117404" cy="117404"/>
             </a:xfrm>
             <a:prstGeom prst="ellipse">
@@ -5531,7 +5531,7 @@
           </p:nvSpPr>
           <p:spPr>
             <a:xfrm>
-              <a:off x="6944276" y="4372015"/>
+              <a:off x="6966250" y="4307193"/>
               <a:ext cx="117404" cy="117404"/>
             </a:xfrm>
             <a:prstGeom prst="ellipse">
@@ -5566,7 +5566,7 @@
           </p:nvSpPr>
           <p:spPr>
             <a:xfrm>
-              <a:off x="4552054" y="5197467"/>
+              <a:off x="4582847" y="4777587"/>
               <a:ext cx="117404" cy="117404"/>
             </a:xfrm>
             <a:prstGeom prst="ellipse">
@@ -5601,7 +5601,7 @@
           </p:nvSpPr>
           <p:spPr>
             <a:xfrm>
-              <a:off x="4992503" y="4864317"/>
+              <a:off x="4990324" y="5568085"/>
               <a:ext cx="117404" cy="117404"/>
             </a:xfrm>
             <a:prstGeom prst="ellipse">
@@ -5636,7 +5636,7 @@
           </p:nvSpPr>
           <p:spPr>
             <a:xfrm>
-              <a:off x="4994965" y="4870370"/>
+              <a:off x="4982692" y="5002553"/>
               <a:ext cx="117404" cy="117404"/>
             </a:xfrm>
             <a:prstGeom prst="ellipse">
@@ -5671,7 +5671,7 @@
           </p:nvSpPr>
           <p:spPr>
             <a:xfrm>
-              <a:off x="4991584" y="4947922"/>
+              <a:off x="4996155" y="4905417"/>
               <a:ext cx="117404" cy="117404"/>
             </a:xfrm>
             <a:prstGeom prst="ellipse">
@@ -5706,7 +5706,7 @@
           </p:nvSpPr>
           <p:spPr>
             <a:xfrm>
-              <a:off x="5253000" y="5317689"/>
+              <a:off x="5276711" y="5282212"/>
               <a:ext cx="117404" cy="117404"/>
             </a:xfrm>
             <a:prstGeom prst="ellipse">
@@ -5741,7 +5741,7 @@
           </p:nvSpPr>
           <p:spPr>
             <a:xfrm>
-              <a:off x="5272876" y="5031904"/>
+              <a:off x="5260964" y="4933895"/>
               <a:ext cx="117404" cy="117404"/>
             </a:xfrm>
             <a:prstGeom prst="ellipse">
@@ -5776,7 +5776,7 @@
           </p:nvSpPr>
           <p:spPr>
             <a:xfrm>
-              <a:off x="5404935" y="4970259"/>
+              <a:off x="5406790" y="4980688"/>
               <a:ext cx="117404" cy="117404"/>
             </a:xfrm>
             <a:prstGeom prst="ellipse">
@@ -5811,7 +5811,7 @@
           </p:nvSpPr>
           <p:spPr>
             <a:xfrm>
-              <a:off x="5675319" y="4906307"/>
+              <a:off x="5691645" y="5207230"/>
               <a:ext cx="117404" cy="117404"/>
             </a:xfrm>
             <a:prstGeom prst="ellipse">
@@ -5846,7 +5846,7 @@
           </p:nvSpPr>
           <p:spPr>
             <a:xfrm>
-              <a:off x="5814193" y="4736642"/>
+              <a:off x="5843295" y="5592764"/>
               <a:ext cx="117404" cy="117404"/>
             </a:xfrm>
             <a:prstGeom prst="ellipse">
@@ -5881,7 +5881,7 @@
           </p:nvSpPr>
           <p:spPr>
             <a:xfrm>
-              <a:off x="5823502" y="4857586"/>
+              <a:off x="5823509" y="5271609"/>
               <a:ext cx="117404" cy="117404"/>
             </a:xfrm>
             <a:prstGeom prst="ellipse">
@@ -5916,7 +5916,7 @@
           </p:nvSpPr>
           <p:spPr>
             <a:xfrm>
-              <a:off x="6114455" y="4931106"/>
+              <a:off x="6118421" y="5392923"/>
               <a:ext cx="117404" cy="117404"/>
             </a:xfrm>
             <a:prstGeom prst="ellipse">
@@ -5951,7 +5951,7 @@
           </p:nvSpPr>
           <p:spPr>
             <a:xfrm>
-              <a:off x="6396707" y="5581319"/>
+              <a:off x="6380853" y="5465624"/>
               <a:ext cx="117404" cy="117404"/>
             </a:xfrm>
             <a:prstGeom prst="ellipse">
@@ -5986,7 +5986,7 @@
           </p:nvSpPr>
           <p:spPr>
             <a:xfrm>
-              <a:off x="6791643" y="5244643"/>
+              <a:off x="6817222" y="5528557"/>
               <a:ext cx="117404" cy="117404"/>
             </a:xfrm>
             <a:prstGeom prst="ellipse">
@@ -6021,7 +6021,7 @@
           </p:nvSpPr>
           <p:spPr>
             <a:xfrm>
-              <a:off x="7096479" y="5199458"/>
+              <a:off x="7107885" y="4800452"/>
               <a:ext cx="117404" cy="117404"/>
             </a:xfrm>
             <a:prstGeom prst="ellipse">
@@ -6056,7 +6056,7 @@
           </p:nvSpPr>
           <p:spPr>
             <a:xfrm>
-              <a:off x="7515348" y="5552714"/>
+              <a:off x="7507308" y="4986843"/>
               <a:ext cx="117404" cy="117404"/>
             </a:xfrm>
             <a:prstGeom prst="ellipse">
@@ -6091,8 +6091,8 @@
           </p:nvSpPr>
           <p:spPr>
             <a:xfrm>
-              <a:off x="3673851" y="1107814"/>
-              <a:ext cx="5263241" cy="4786991"/>
+              <a:off x="3678613" y="1107814"/>
+              <a:ext cx="5258478" cy="4777466"/>
             </a:xfrm>
             <a:prstGeom prst="rect">
               <a:avLst/>
@@ -6121,15 +6121,15 @@
           </p:nvSpPr>
           <p:spPr>
             <a:xfrm>
-              <a:off x="3673851" y="1107814"/>
-              <a:ext cx="0" cy="4786991"/>
+              <a:off x="3678613" y="1107814"/>
+              <a:ext cx="0" cy="4777466"/>
             </a:xfrm>
             <a:custGeom>
               <a:avLst/>
               <a:pathLst>
-                <a:path w="0" h="4786991">
+                <a:path w="0" h="4777466">
                   <a:moveTo>
-                    <a:pt x="0" y="4786991"/>
+                    <a:pt x="0" y="4777466"/>
                   </a:moveTo>
                   <a:lnTo>
                     <a:pt x="0" y="0"/>
@@ -6161,7 +6161,7 @@
           </p:nvSpPr>
           <p:spPr>
             <a:xfrm>
-              <a:off x="2079655" y="5063485"/>
+              <a:off x="2084417" y="5055321"/>
               <a:ext cx="1531565" cy="238373"/>
             </a:xfrm>
             <a:prstGeom prst="rect">
@@ -6207,7 +6207,7 @@
           </p:nvSpPr>
           <p:spPr>
             <a:xfrm>
-              <a:off x="1994451" y="3923725"/>
+              <a:off x="1999213" y="3917829"/>
               <a:ext cx="1616769" cy="238373"/>
             </a:xfrm>
             <a:prstGeom prst="rect">
@@ -6253,7 +6253,7 @@
           </p:nvSpPr>
           <p:spPr>
             <a:xfrm>
-              <a:off x="2149976" y="2783965"/>
+              <a:off x="2154739" y="2780337"/>
               <a:ext cx="1461244" cy="238373"/>
             </a:xfrm>
             <a:prstGeom prst="rect">
@@ -6299,7 +6299,7 @@
           </p:nvSpPr>
           <p:spPr>
             <a:xfrm>
-              <a:off x="2037115" y="1644206"/>
+              <a:off x="2041877" y="1642845"/>
               <a:ext cx="1574105" cy="238373"/>
             </a:xfrm>
             <a:prstGeom prst="rect">
@@ -6345,7 +6345,7 @@
           </p:nvSpPr>
           <p:spPr>
             <a:xfrm>
-              <a:off x="3639056" y="5210949"/>
+              <a:off x="3643819" y="5202785"/>
               <a:ext cx="34794" cy="0"/>
             </a:xfrm>
             <a:custGeom>
@@ -6385,7 +6385,7 @@
           </p:nvSpPr>
           <p:spPr>
             <a:xfrm>
-              <a:off x="3639056" y="4071189"/>
+              <a:off x="3643819" y="4065293"/>
               <a:ext cx="34794" cy="0"/>
             </a:xfrm>
             <a:custGeom>
@@ -6425,7 +6425,7 @@
           </p:nvSpPr>
           <p:spPr>
             <a:xfrm>
-              <a:off x="3639056" y="2931429"/>
+              <a:off x="3643819" y="2927801"/>
               <a:ext cx="34794" cy="0"/>
             </a:xfrm>
             <a:custGeom>
@@ -6465,7 +6465,7 @@
           </p:nvSpPr>
           <p:spPr>
             <a:xfrm>
-              <a:off x="3639056" y="1791669"/>
+              <a:off x="3643819" y="1790309"/>
               <a:ext cx="34794" cy="0"/>
             </a:xfrm>
             <a:custGeom>
@@ -6505,18 +6505,18 @@
           </p:nvSpPr>
           <p:spPr>
             <a:xfrm>
-              <a:off x="3673851" y="5894805"/>
-              <a:ext cx="5263241" cy="0"/>
+              <a:off x="3678613" y="5885280"/>
+              <a:ext cx="5258478" cy="0"/>
             </a:xfrm>
             <a:custGeom>
               <a:avLst/>
               <a:pathLst>
-                <a:path w="5263241" h="0">
+                <a:path w="5258478" h="0">
                   <a:moveTo>
                     <a:pt x="0" y="0"/>
                   </a:moveTo>
                   <a:lnTo>
-                    <a:pt x="5263241" y="0"/>
+                    <a:pt x="5258478" y="0"/>
                   </a:lnTo>
                 </a:path>
               </a:pathLst>
@@ -6545,7 +6545,7 @@
           </p:nvSpPr>
           <p:spPr>
             <a:xfrm>
-              <a:off x="3778466" y="5894805"/>
+              <a:off x="3785734" y="5885280"/>
               <a:ext cx="0" cy="34794"/>
             </a:xfrm>
             <a:custGeom>
@@ -6585,7 +6585,7 @@
           </p:nvSpPr>
           <p:spPr>
             <a:xfrm>
-              <a:off x="5180060" y="5894805"/>
+              <a:off x="5188878" y="5885280"/>
               <a:ext cx="0" cy="34794"/>
             </a:xfrm>
             <a:custGeom>
@@ -6625,7 +6625,7 @@
           </p:nvSpPr>
           <p:spPr>
             <a:xfrm>
-              <a:off x="6581655" y="5894805"/>
+              <a:off x="6592021" y="5885280"/>
               <a:ext cx="0" cy="34794"/>
             </a:xfrm>
             <a:custGeom>
@@ -6665,7 +6665,7 @@
           </p:nvSpPr>
           <p:spPr>
             <a:xfrm>
-              <a:off x="7983250" y="5894805"/>
+              <a:off x="7995165" y="5885280"/>
               <a:ext cx="0" cy="34794"/>
             </a:xfrm>
             <a:custGeom>
@@ -6705,7 +6705,7 @@
           </p:nvSpPr>
           <p:spPr>
             <a:xfrm>
-              <a:off x="3566572" y="5953590"/>
+              <a:off x="3573840" y="5944065"/>
               <a:ext cx="423788" cy="185663"/>
             </a:xfrm>
             <a:prstGeom prst="rect">
@@ -6751,7 +6751,7 @@
           </p:nvSpPr>
           <p:spPr>
             <a:xfrm>
-              <a:off x="4968166" y="5953590"/>
+              <a:off x="4976984" y="5944065"/>
               <a:ext cx="423788" cy="185663"/>
             </a:xfrm>
             <a:prstGeom prst="rect">
@@ -6797,7 +6797,7 @@
           </p:nvSpPr>
           <p:spPr>
             <a:xfrm>
-              <a:off x="6369761" y="5953466"/>
+              <a:off x="6380127" y="5943941"/>
               <a:ext cx="423788" cy="185787"/>
             </a:xfrm>
             <a:prstGeom prst="rect">
@@ -6843,7 +6843,7 @@
           </p:nvSpPr>
           <p:spPr>
             <a:xfrm>
-              <a:off x="7771356" y="5953590"/>
+              <a:off x="7783271" y="5944065"/>
               <a:ext cx="423788" cy="185663"/>
             </a:xfrm>
             <a:prstGeom prst="rect">
@@ -6889,7 +6889,7 @@
           </p:nvSpPr>
           <p:spPr>
             <a:xfrm>
-              <a:off x="5691183" y="6222492"/>
+              <a:off x="5693564" y="6217729"/>
               <a:ext cx="1228576" cy="184918"/>
             </a:xfrm>
             <a:prstGeom prst="rect">
@@ -6935,7 +6935,7 @@
           </p:nvSpPr>
           <p:spPr>
             <a:xfrm rot="-5400000">
-              <a:off x="1227583" y="3407237"/>
+              <a:off x="1227583" y="3402475"/>
               <a:ext cx="1242466" cy="188143"/>
             </a:xfrm>
             <a:prstGeom prst="rect">

</xml_diff>

<commit_message>
correct order of the first analysis
</commit_message>
<xml_diff>
--- a/Figures/Figure1.pptx
+++ b/Figures/Figure1.pptx
@@ -3218,18 +3218,18 @@
           </p:nvSpPr>
           <p:spPr>
             <a:xfrm>
-              <a:off x="6311393" y="5202785"/>
-              <a:ext cx="1262829" cy="0"/>
+              <a:off x="6307329" y="5202785"/>
+              <a:ext cx="1265132" cy="0"/>
             </a:xfrm>
             <a:custGeom>
               <a:avLst/>
               <a:pathLst>
-                <a:path w="1262829" h="0">
+                <a:path w="1265132" h="0">
                   <a:moveTo>
                     <a:pt x="0" y="0"/>
                   </a:moveTo>
                   <a:lnTo>
-                    <a:pt x="1262829" y="0"/>
+                    <a:pt x="1265132" y="0"/>
                   </a:lnTo>
                 </a:path>
               </a:pathLst>
@@ -3258,15 +3258,15 @@
           </p:nvSpPr>
           <p:spPr>
             <a:xfrm>
-              <a:off x="4627620" y="5202785"/>
-              <a:ext cx="561257" cy="0"/>
+              <a:off x="4620486" y="5202785"/>
+              <a:ext cx="562280" cy="0"/>
             </a:xfrm>
             <a:custGeom>
               <a:avLst/>
               <a:pathLst>
-                <a:path w="561257" h="0">
+                <a:path w="562280" h="0">
                   <a:moveTo>
-                    <a:pt x="561257" y="0"/>
+                    <a:pt x="562280" y="0"/>
                   </a:moveTo>
                   <a:lnTo>
                     <a:pt x="0" y="0"/>
@@ -3298,15 +3298,15 @@
           </p:nvSpPr>
           <p:spPr>
             <a:xfrm>
-              <a:off x="5188878" y="4776225"/>
-              <a:ext cx="1122514" cy="853119"/>
+              <a:off x="5182767" y="4776225"/>
+              <a:ext cx="1124561" cy="853119"/>
             </a:xfrm>
             <a:custGeom>
               <a:avLst/>
               <a:pathLst>
-                <a:path w="1122514" h="853119">
+                <a:path w="1124561" h="853119">
                   <a:moveTo>
-                    <a:pt x="1122514" y="853119"/>
+                    <a:pt x="1124561" y="853119"/>
                   </a:moveTo>
                   <a:lnTo>
                     <a:pt x="0" y="853119"/>
@@ -3315,7 +3315,7 @@
                     <a:pt x="0" y="0"/>
                   </a:lnTo>
                   <a:lnTo>
-                    <a:pt x="1122514" y="0"/>
+                    <a:pt x="1124561" y="0"/>
                   </a:lnTo>
                   <a:close/>
                 </a:path>
@@ -3345,7 +3345,7 @@
           </p:nvSpPr>
           <p:spPr>
             <a:xfrm>
-              <a:off x="5750135" y="4776225"/>
+              <a:off x="5745048" y="4776225"/>
               <a:ext cx="0" cy="853119"/>
             </a:xfrm>
             <a:custGeom>
@@ -3385,7 +3385,7 @@
           </p:nvSpPr>
           <p:spPr>
             <a:xfrm>
-              <a:off x="3901222" y="4040467"/>
+              <a:off x="3892809" y="4040467"/>
               <a:ext cx="49651" cy="49651"/>
             </a:xfrm>
             <a:prstGeom prst="ellipse">
@@ -3420,18 +3420,18 @@
           </p:nvSpPr>
           <p:spPr>
             <a:xfrm>
-              <a:off x="6171078" y="4065293"/>
-              <a:ext cx="841886" cy="0"/>
+              <a:off x="6166759" y="4065293"/>
+              <a:ext cx="843421" cy="0"/>
             </a:xfrm>
             <a:custGeom>
               <a:avLst/>
               <a:pathLst>
-                <a:path w="841886" h="0">
+                <a:path w="843421" h="0">
                   <a:moveTo>
                     <a:pt x="0" y="0"/>
                   </a:moveTo>
                   <a:lnTo>
-                    <a:pt x="841886" y="0"/>
+                    <a:pt x="843421" y="0"/>
                   </a:lnTo>
                 </a:path>
               </a:pathLst>
@@ -3460,15 +3460,15 @@
           </p:nvSpPr>
           <p:spPr>
             <a:xfrm>
-              <a:off x="5048563" y="4065293"/>
-              <a:ext cx="456021" cy="0"/>
+              <a:off x="5042197" y="4065293"/>
+              <a:ext cx="456853" cy="0"/>
             </a:xfrm>
             <a:custGeom>
               <a:avLst/>
               <a:pathLst>
-                <a:path w="456021" h="0">
+                <a:path w="456853" h="0">
                   <a:moveTo>
-                    <a:pt x="456021" y="0"/>
+                    <a:pt x="456853" y="0"/>
                   </a:moveTo>
                   <a:lnTo>
                     <a:pt x="0" y="0"/>
@@ -3500,15 +3500,15 @@
           </p:nvSpPr>
           <p:spPr>
             <a:xfrm>
-              <a:off x="5504585" y="3638733"/>
-              <a:ext cx="666493" cy="853119"/>
+              <a:off x="5499050" y="3638733"/>
+              <a:ext cx="667708" cy="853119"/>
             </a:xfrm>
             <a:custGeom>
               <a:avLst/>
               <a:pathLst>
-                <a:path w="666493" h="853119">
+                <a:path w="667708" h="853119">
                   <a:moveTo>
-                    <a:pt x="666493" y="853119"/>
+                    <a:pt x="667708" y="853119"/>
                   </a:moveTo>
                   <a:lnTo>
                     <a:pt x="0" y="853119"/>
@@ -3517,7 +3517,7 @@
                     <a:pt x="0" y="0"/>
                   </a:lnTo>
                   <a:lnTo>
-                    <a:pt x="666493" y="0"/>
+                    <a:pt x="667708" y="0"/>
                   </a:lnTo>
                   <a:close/>
                 </a:path>
@@ -3547,7 +3547,7 @@
           </p:nvSpPr>
           <p:spPr>
             <a:xfrm>
-              <a:off x="6030764" y="3638733"/>
+              <a:off x="6026188" y="3638733"/>
               <a:ext cx="0" cy="853119"/>
             </a:xfrm>
             <a:custGeom>
@@ -3587,18 +3587,18 @@
           </p:nvSpPr>
           <p:spPr>
             <a:xfrm>
-              <a:off x="6662179" y="2927801"/>
-              <a:ext cx="912043" cy="0"/>
+              <a:off x="6658754" y="2927801"/>
+              <a:ext cx="913706" cy="0"/>
             </a:xfrm>
             <a:custGeom>
               <a:avLst/>
               <a:pathLst>
-                <a:path w="912043" h="0">
+                <a:path w="913706" h="0">
                   <a:moveTo>
                     <a:pt x="0" y="0"/>
                   </a:moveTo>
                   <a:lnTo>
-                    <a:pt x="912043" y="0"/>
+                    <a:pt x="913706" y="0"/>
                   </a:lnTo>
                 </a:path>
               </a:pathLst>
@@ -3627,15 +3627,15 @@
           </p:nvSpPr>
           <p:spPr>
             <a:xfrm>
-              <a:off x="4066363" y="2927801"/>
-              <a:ext cx="1227750" cy="0"/>
+              <a:off x="4058205" y="2927801"/>
+              <a:ext cx="1229989" cy="0"/>
             </a:xfrm>
             <a:custGeom>
               <a:avLst/>
               <a:pathLst>
-                <a:path w="1227750" h="0">
+                <a:path w="1229989" h="0">
                   <a:moveTo>
-                    <a:pt x="1227750" y="0"/>
+                    <a:pt x="1229989" y="0"/>
                   </a:moveTo>
                   <a:lnTo>
                     <a:pt x="0" y="0"/>
@@ -3667,15 +3667,15 @@
           </p:nvSpPr>
           <p:spPr>
             <a:xfrm>
-              <a:off x="5294113" y="2501241"/>
-              <a:ext cx="1368065" cy="853119"/>
+              <a:off x="5288195" y="2501241"/>
+              <a:ext cx="1370559" cy="853119"/>
             </a:xfrm>
             <a:custGeom>
               <a:avLst/>
               <a:pathLst>
-                <a:path w="1368065" h="853119">
+                <a:path w="1370559" h="853119">
                   <a:moveTo>
-                    <a:pt x="1368065" y="853119"/>
+                    <a:pt x="1370559" y="853119"/>
                   </a:moveTo>
                   <a:lnTo>
                     <a:pt x="0" y="853119"/>
@@ -3684,7 +3684,7 @@
                     <a:pt x="0" y="0"/>
                   </a:lnTo>
                   <a:lnTo>
-                    <a:pt x="1368065" y="0"/>
+                    <a:pt x="1370559" y="0"/>
                   </a:lnTo>
                   <a:close/>
                 </a:path>
@@ -3714,7 +3714,7 @@
           </p:nvSpPr>
           <p:spPr>
             <a:xfrm>
-              <a:off x="5750135" y="2501241"/>
+              <a:off x="5745048" y="2501241"/>
               <a:ext cx="0" cy="853119"/>
             </a:xfrm>
             <a:custGeom>
@@ -3754,7 +3754,7 @@
           </p:nvSpPr>
           <p:spPr>
             <a:xfrm>
-              <a:off x="8671911" y="1765483"/>
+              <a:off x="8672197" y="1765483"/>
               <a:ext cx="49651" cy="49651"/>
             </a:xfrm>
             <a:prstGeom prst="ellipse">
@@ -3789,18 +3789,18 @@
           </p:nvSpPr>
           <p:spPr>
             <a:xfrm>
-              <a:off x="6556943" y="1790309"/>
-              <a:ext cx="1438222" cy="0"/>
+              <a:off x="6553327" y="1790309"/>
+              <a:ext cx="1440844" cy="0"/>
             </a:xfrm>
             <a:custGeom>
               <a:avLst/>
               <a:pathLst>
-                <a:path w="1438222" h="0">
+                <a:path w="1440844" h="0">
                   <a:moveTo>
                     <a:pt x="0" y="0"/>
                   </a:moveTo>
                   <a:lnTo>
-                    <a:pt x="1438222" y="0"/>
+                    <a:pt x="1440844" y="0"/>
                   </a:lnTo>
                 </a:path>
               </a:pathLst>
@@ -3829,15 +3829,15 @@
           </p:nvSpPr>
           <p:spPr>
             <a:xfrm>
-              <a:off x="4908249" y="1790309"/>
-              <a:ext cx="245550" cy="0"/>
+              <a:off x="4901626" y="1790309"/>
+              <a:ext cx="245997" cy="0"/>
             </a:xfrm>
             <a:custGeom>
               <a:avLst/>
               <a:pathLst>
-                <a:path w="245550" h="0">
+                <a:path w="245997" h="0">
                   <a:moveTo>
-                    <a:pt x="245550" y="0"/>
+                    <a:pt x="245997" y="0"/>
                   </a:moveTo>
                   <a:lnTo>
                     <a:pt x="0" y="0"/>
@@ -3869,15 +3869,15 @@
           </p:nvSpPr>
           <p:spPr>
             <a:xfrm>
-              <a:off x="5153799" y="1363749"/>
-              <a:ext cx="1403143" cy="853119"/>
+              <a:off x="5147624" y="1363749"/>
+              <a:ext cx="1405702" cy="853119"/>
             </a:xfrm>
             <a:custGeom>
               <a:avLst/>
               <a:pathLst>
-                <a:path w="1403143" h="853119">
+                <a:path w="1405702" h="853119">
                   <a:moveTo>
-                    <a:pt x="1403143" y="853119"/>
+                    <a:pt x="1405702" y="853119"/>
                   </a:moveTo>
                   <a:lnTo>
                     <a:pt x="0" y="853119"/>
@@ -3886,7 +3886,7 @@
                     <a:pt x="0" y="0"/>
                   </a:lnTo>
                   <a:lnTo>
-                    <a:pt x="1403143" y="0"/>
+                    <a:pt x="1405702" y="0"/>
                   </a:lnTo>
                   <a:close/>
                 </a:path>
@@ -3916,7 +3916,7 @@
           </p:nvSpPr>
           <p:spPr>
             <a:xfrm>
-              <a:off x="5750135" y="1363749"/>
+              <a:off x="5745048" y="1363749"/>
               <a:ext cx="0" cy="853119"/>
             </a:xfrm>
             <a:custGeom>
@@ -3956,7 +3956,7 @@
           </p:nvSpPr>
           <p:spPr>
             <a:xfrm>
-              <a:off x="4017191" y="3187857"/>
+              <a:off x="3992986" y="3200049"/>
               <a:ext cx="117404" cy="117404"/>
             </a:xfrm>
             <a:prstGeom prst="ellipse">
@@ -3991,7 +3991,7 @@
           </p:nvSpPr>
           <p:spPr>
             <a:xfrm>
-              <a:off x="4861982" y="3270988"/>
+              <a:off x="4833232" y="2880124"/>
               <a:ext cx="117404" cy="117404"/>
             </a:xfrm>
             <a:prstGeom prst="ellipse">
@@ -4026,7 +4026,7 @@
           </p:nvSpPr>
           <p:spPr>
             <a:xfrm>
-              <a:off x="4976861" y="2619060"/>
+              <a:off x="4982210" y="2414283"/>
               <a:ext cx="117404" cy="117404"/>
             </a:xfrm>
             <a:prstGeom prst="ellipse">
@@ -4061,7 +4061,7 @@
           </p:nvSpPr>
           <p:spPr>
             <a:xfrm>
-              <a:off x="5126632" y="2584118"/>
+              <a:off x="5115098" y="3110395"/>
               <a:ext cx="117404" cy="117404"/>
             </a:xfrm>
             <a:prstGeom prst="ellipse">
@@ -4096,7 +4096,7 @@
           </p:nvSpPr>
           <p:spPr>
             <a:xfrm>
-              <a:off x="5269698" y="2579369"/>
+              <a:off x="5276300" y="3205210"/>
               <a:ext cx="117404" cy="117404"/>
             </a:xfrm>
             <a:prstGeom prst="ellipse">
@@ -4131,7 +4131,7 @@
           </p:nvSpPr>
           <p:spPr>
             <a:xfrm>
-              <a:off x="5274943" y="2583713"/>
+              <a:off x="5263933" y="3173498"/>
               <a:ext cx="117404" cy="117404"/>
             </a:xfrm>
             <a:prstGeom prst="ellipse">
@@ -4166,7 +4166,7 @@
           </p:nvSpPr>
           <p:spPr>
             <a:xfrm>
-              <a:off x="5401361" y="2889868"/>
+              <a:off x="5391985" y="3224400"/>
               <a:ext cx="117404" cy="117404"/>
             </a:xfrm>
             <a:prstGeom prst="ellipse">
@@ -4201,7 +4201,7 @@
           </p:nvSpPr>
           <p:spPr>
             <a:xfrm>
-              <a:off x="5553041" y="2905242"/>
+              <a:off x="5558624" y="2501094"/>
               <a:ext cx="117404" cy="117404"/>
             </a:xfrm>
             <a:prstGeom prst="ellipse">
@@ -4236,7 +4236,7 @@
           </p:nvSpPr>
           <p:spPr>
             <a:xfrm>
-              <a:off x="5836495" y="2561729"/>
+              <a:off x="5834735" y="3321080"/>
               <a:ext cx="117404" cy="117404"/>
             </a:xfrm>
             <a:prstGeom prst="ellipse">
@@ -4271,7 +4271,7 @@
           </p:nvSpPr>
           <p:spPr>
             <a:xfrm>
-              <a:off x="6111624" y="2934589"/>
+              <a:off x="6117892" y="3261820"/>
               <a:ext cx="117404" cy="117404"/>
             </a:xfrm>
             <a:prstGeom prst="ellipse">
@@ -4306,7 +4306,7 @@
           </p:nvSpPr>
           <p:spPr>
             <a:xfrm>
-              <a:off x="6381613" y="2838962"/>
+              <a:off x="6379142" y="3249234"/>
               <a:ext cx="117404" cy="117404"/>
             </a:xfrm>
             <a:prstGeom prst="ellipse">
@@ -4341,7 +4341,7 @@
           </p:nvSpPr>
           <p:spPr>
             <a:xfrm>
-              <a:off x="6541625" y="2809268"/>
+              <a:off x="6523594" y="3298454"/>
               <a:ext cx="117404" cy="117404"/>
             </a:xfrm>
             <a:prstGeom prst="ellipse">
@@ -4376,7 +4376,7 @@
           </p:nvSpPr>
           <p:spPr>
             <a:xfrm>
-              <a:off x="6802678" y="2872216"/>
+              <a:off x="6821917" y="2867111"/>
               <a:ext cx="117404" cy="117404"/>
             </a:xfrm>
             <a:prstGeom prst="ellipse">
@@ -4411,7 +4411,7 @@
           </p:nvSpPr>
           <p:spPr>
             <a:xfrm>
-              <a:off x="6965086" y="2932758"/>
+              <a:off x="6957571" y="3190289"/>
               <a:ext cx="117404" cy="117404"/>
             </a:xfrm>
             <a:prstGeom prst="ellipse">
@@ -4446,7 +4446,7 @@
           </p:nvSpPr>
           <p:spPr>
             <a:xfrm>
-              <a:off x="6940631" y="3068529"/>
+              <a:off x="6963672" y="2631525"/>
               <a:ext cx="117404" cy="117404"/>
             </a:xfrm>
             <a:prstGeom prst="ellipse">
@@ -4481,7 +4481,7 @@
           </p:nvSpPr>
           <p:spPr>
             <a:xfrm>
-              <a:off x="7528745" y="3186841"/>
+              <a:off x="7502129" y="3184885"/>
               <a:ext cx="117404" cy="117404"/>
             </a:xfrm>
             <a:prstGeom prst="ellipse">
@@ -4516,7 +4516,7 @@
           </p:nvSpPr>
           <p:spPr>
             <a:xfrm>
-              <a:off x="4856175" y="2140858"/>
+              <a:off x="4850461" y="1787871"/>
               <a:ext cx="117404" cy="117404"/>
             </a:xfrm>
             <a:prstGeom prst="ellipse">
@@ -4551,7 +4551,7 @@
           </p:nvSpPr>
           <p:spPr>
             <a:xfrm>
-              <a:off x="4979277" y="1557867"/>
+              <a:off x="4972342" y="1927980"/>
               <a:ext cx="117404" cy="117404"/>
             </a:xfrm>
             <a:prstGeom prst="ellipse">
@@ -4586,7 +4586,7 @@
           </p:nvSpPr>
           <p:spPr>
             <a:xfrm>
-              <a:off x="4984400" y="1509819"/>
+              <a:off x="4972361" y="1587279"/>
               <a:ext cx="117404" cy="117404"/>
             </a:xfrm>
             <a:prstGeom prst="ellipse">
@@ -4621,7 +4621,7 @@
           </p:nvSpPr>
           <p:spPr>
             <a:xfrm>
-              <a:off x="4988318" y="2103161"/>
+              <a:off x="4982870" y="1573869"/>
               <a:ext cx="117404" cy="117404"/>
             </a:xfrm>
             <a:prstGeom prst="ellipse">
@@ -4656,7 +4656,7 @@
           </p:nvSpPr>
           <p:spPr>
             <a:xfrm>
-              <a:off x="5002995" y="1513667"/>
+              <a:off x="4973579" y="2122760"/>
               <a:ext cx="117404" cy="117404"/>
             </a:xfrm>
             <a:prstGeom prst="ellipse">
@@ -4691,7 +4691,7 @@
           </p:nvSpPr>
           <p:spPr>
             <a:xfrm>
-              <a:off x="5124498" y="1695569"/>
+              <a:off x="5118402" y="1361771"/>
               <a:ext cx="117404" cy="117404"/>
             </a:xfrm>
             <a:prstGeom prst="ellipse">
@@ -4726,7 +4726,7 @@
           </p:nvSpPr>
           <p:spPr>
             <a:xfrm>
-              <a:off x="5279365" y="1410323"/>
+              <a:off x="5257107" y="1861533"/>
               <a:ext cx="117404" cy="117404"/>
             </a:xfrm>
             <a:prstGeom prst="ellipse">
@@ -4761,7 +4761,7 @@
           </p:nvSpPr>
           <p:spPr>
             <a:xfrm>
-              <a:off x="5261074" y="1379796"/>
+              <a:off x="5276477" y="1280228"/>
               <a:ext cx="117404" cy="117404"/>
             </a:xfrm>
             <a:prstGeom prst="ellipse">
@@ -4796,7 +4796,7 @@
           </p:nvSpPr>
           <p:spPr>
             <a:xfrm>
-              <a:off x="5537329" y="1470848"/>
+              <a:off x="5541624" y="1956608"/>
               <a:ext cx="117404" cy="117404"/>
             </a:xfrm>
             <a:prstGeom prst="ellipse">
@@ -4831,7 +4831,7 @@
           </p:nvSpPr>
           <p:spPr>
             <a:xfrm>
-              <a:off x="5681137" y="1821848"/>
+              <a:off x="5691740" y="1351559"/>
               <a:ext cx="117404" cy="117404"/>
             </a:xfrm>
             <a:prstGeom prst="ellipse">
@@ -4866,7 +4866,7 @@
           </p:nvSpPr>
           <p:spPr>
             <a:xfrm>
-              <a:off x="5683133" y="1781743"/>
+              <a:off x="5676460" y="2184000"/>
               <a:ext cx="117404" cy="117404"/>
             </a:xfrm>
             <a:prstGeom prst="ellipse">
@@ -4901,7 +4901,7 @@
           </p:nvSpPr>
           <p:spPr>
             <a:xfrm>
-              <a:off x="5983441" y="1501853"/>
+              <a:off x="5962829" y="1930695"/>
               <a:ext cx="117404" cy="117404"/>
             </a:xfrm>
             <a:prstGeom prst="ellipse">
@@ -4936,7 +4936,7 @@
           </p:nvSpPr>
           <p:spPr>
             <a:xfrm>
-              <a:off x="6386075" y="1455012"/>
+              <a:off x="6388903" y="1937645"/>
               <a:ext cx="117404" cy="117404"/>
             </a:xfrm>
             <a:prstGeom prst="ellipse">
@@ -4971,7 +4971,7 @@
           </p:nvSpPr>
           <p:spPr>
             <a:xfrm>
-              <a:off x="6393731" y="1313874"/>
+              <a:off x="6402320" y="1997473"/>
               <a:ext cx="117404" cy="117404"/>
             </a:xfrm>
             <a:prstGeom prst="ellipse">
@@ -5006,7 +5006,7 @@
           </p:nvSpPr>
           <p:spPr>
             <a:xfrm>
-              <a:off x="6403933" y="1627232"/>
+              <a:off x="6386999" y="1864512"/>
               <a:ext cx="117404" cy="117404"/>
             </a:xfrm>
             <a:prstGeom prst="ellipse">
@@ -5041,7 +5041,7 @@
           </p:nvSpPr>
           <p:spPr>
             <a:xfrm>
-              <a:off x="6827845" y="1642752"/>
+              <a:off x="6823579" y="1773912"/>
               <a:ext cx="117404" cy="117404"/>
             </a:xfrm>
             <a:prstGeom prst="ellipse">
@@ -5076,7 +5076,7 @@
           </p:nvSpPr>
           <p:spPr>
             <a:xfrm>
-              <a:off x="6960902" y="2114340"/>
+              <a:off x="6940418" y="1889551"/>
               <a:ext cx="117404" cy="117404"/>
             </a:xfrm>
             <a:prstGeom prst="ellipse">
@@ -5111,7 +5111,7 @@
           </p:nvSpPr>
           <p:spPr>
             <a:xfrm>
-              <a:off x="7236445" y="2117074"/>
+              <a:off x="7238730" y="1555386"/>
               <a:ext cx="117404" cy="117404"/>
             </a:xfrm>
             <a:prstGeom prst="ellipse">
@@ -5146,7 +5146,7 @@
           </p:nvSpPr>
           <p:spPr>
             <a:xfrm>
-              <a:off x="7946228" y="1733864"/>
+              <a:off x="7926373" y="1794140"/>
               <a:ext cx="117404" cy="117404"/>
             </a:xfrm>
             <a:prstGeom prst="ellipse">
@@ -5181,7 +5181,7 @@
           </p:nvSpPr>
           <p:spPr>
             <a:xfrm>
-              <a:off x="8639368" y="1996449"/>
+              <a:off x="8639368" y="1282261"/>
               <a:ext cx="117404" cy="117404"/>
             </a:xfrm>
             <a:prstGeom prst="ellipse">
@@ -5216,7 +5216,7 @@
           </p:nvSpPr>
           <p:spPr>
             <a:xfrm>
-              <a:off x="3858932" y="3618763"/>
+              <a:off x="3868288" y="4102742"/>
               <a:ext cx="117404" cy="117404"/>
             </a:xfrm>
             <a:prstGeom prst="ellipse">
@@ -5251,7 +5251,7 @@
           </p:nvSpPr>
           <p:spPr>
             <a:xfrm>
-              <a:off x="4992950" y="3904661"/>
+              <a:off x="4972554" y="4333266"/>
               <a:ext cx="117404" cy="117404"/>
             </a:xfrm>
             <a:prstGeom prst="ellipse">
@@ -5286,7 +5286,7 @@
           </p:nvSpPr>
           <p:spPr>
             <a:xfrm>
-              <a:off x="5411029" y="4154684"/>
+              <a:off x="5398981" y="3581660"/>
               <a:ext cx="117404" cy="117404"/>
             </a:xfrm>
             <a:prstGeom prst="ellipse">
@@ -5321,7 +5321,7 @@
           </p:nvSpPr>
           <p:spPr>
             <a:xfrm>
-              <a:off x="5562369" y="3564222"/>
+              <a:off x="5554464" y="4447982"/>
               <a:ext cx="117404" cy="117404"/>
             </a:xfrm>
             <a:prstGeom prst="ellipse">
@@ -5356,7 +5356,7 @@
           </p:nvSpPr>
           <p:spPr>
             <a:xfrm>
-              <a:off x="5959121" y="4238538"/>
+              <a:off x="5966370" y="4389657"/>
               <a:ext cx="117404" cy="117404"/>
             </a:xfrm>
             <a:prstGeom prst="ellipse">
@@ -5391,7 +5391,7 @@
           </p:nvSpPr>
           <p:spPr>
             <a:xfrm>
-              <a:off x="5969017" y="3796075"/>
+              <a:off x="5974300" y="4118753"/>
               <a:ext cx="117404" cy="117404"/>
             </a:xfrm>
             <a:prstGeom prst="ellipse">
@@ -5426,7 +5426,7 @@
           </p:nvSpPr>
           <p:spPr>
             <a:xfrm>
-              <a:off x="6118005" y="4373788"/>
+              <a:off x="6104761" y="3920755"/>
               <a:ext cx="117404" cy="117404"/>
             </a:xfrm>
             <a:prstGeom prst="ellipse">
@@ -5461,7 +5461,7 @@
           </p:nvSpPr>
           <p:spPr>
             <a:xfrm>
-              <a:off x="6106509" y="3598941"/>
+              <a:off x="6119139" y="4081885"/>
               <a:ext cx="117404" cy="117404"/>
             </a:xfrm>
             <a:prstGeom prst="ellipse">
@@ -5496,7 +5496,7 @@
           </p:nvSpPr>
           <p:spPr>
             <a:xfrm>
-              <a:off x="6674510" y="4356160"/>
+              <a:off x="6660833" y="3686971"/>
               <a:ext cx="117404" cy="117404"/>
             </a:xfrm>
             <a:prstGeom prst="ellipse">
@@ -5531,7 +5531,7 @@
           </p:nvSpPr>
           <p:spPr>
             <a:xfrm>
-              <a:off x="6966250" y="4307193"/>
+              <a:off x="6958295" y="3846630"/>
               <a:ext cx="117404" cy="117404"/>
             </a:xfrm>
             <a:prstGeom prst="ellipse">
@@ -5566,7 +5566,7 @@
           </p:nvSpPr>
           <p:spPr>
             <a:xfrm>
-              <a:off x="4582847" y="4777587"/>
+              <a:off x="4561582" y="4797036"/>
               <a:ext cx="117404" cy="117404"/>
             </a:xfrm>
             <a:prstGeom prst="ellipse">
@@ -5601,7 +5601,7 @@
           </p:nvSpPr>
           <p:spPr>
             <a:xfrm>
-              <a:off x="4990324" y="5568085"/>
+              <a:off x="4993234" y="4914455"/>
               <a:ext cx="117404" cy="117404"/>
             </a:xfrm>
             <a:prstGeom prst="ellipse">
@@ -5636,7 +5636,7 @@
           </p:nvSpPr>
           <p:spPr>
             <a:xfrm>
-              <a:off x="4982692" y="5002553"/>
+              <a:off x="4988620" y="4755427"/>
               <a:ext cx="117404" cy="117404"/>
             </a:xfrm>
             <a:prstGeom prst="ellipse">
@@ -5671,7 +5671,7 @@
           </p:nvSpPr>
           <p:spPr>
             <a:xfrm>
-              <a:off x="4996155" y="4905417"/>
+              <a:off x="4997483" y="5291802"/>
               <a:ext cx="117404" cy="117404"/>
             </a:xfrm>
             <a:prstGeom prst="ellipse">
@@ -5706,7 +5706,7 @@
           </p:nvSpPr>
           <p:spPr>
             <a:xfrm>
-              <a:off x="5276711" y="5282212"/>
+              <a:off x="5264977" y="4848727"/>
               <a:ext cx="117404" cy="117404"/>
             </a:xfrm>
             <a:prstGeom prst="ellipse">
@@ -5741,7 +5741,7 @@
           </p:nvSpPr>
           <p:spPr>
             <a:xfrm>
-              <a:off x="5260964" y="4933895"/>
+              <a:off x="5262136" y="5134014"/>
               <a:ext cx="117404" cy="117404"/>
             </a:xfrm>
             <a:prstGeom prst="ellipse">
@@ -5776,7 +5776,7 @@
           </p:nvSpPr>
           <p:spPr>
             <a:xfrm>
-              <a:off x="5406790" y="4980688"/>
+              <a:off x="5417453" y="5136285"/>
               <a:ext cx="117404" cy="117404"/>
             </a:xfrm>
             <a:prstGeom prst="ellipse">
@@ -5811,7 +5811,7 @@
           </p:nvSpPr>
           <p:spPr>
             <a:xfrm>
-              <a:off x="5691645" y="5207230"/>
+              <a:off x="5684614" y="4951711"/>
               <a:ext cx="117404" cy="117404"/>
             </a:xfrm>
             <a:prstGeom prst="ellipse">
@@ -5846,7 +5846,7 @@
           </p:nvSpPr>
           <p:spPr>
             <a:xfrm>
-              <a:off x="5843295" y="5592764"/>
+              <a:off x="5836527" y="5242488"/>
               <a:ext cx="117404" cy="117404"/>
             </a:xfrm>
             <a:prstGeom prst="ellipse">
@@ -5881,7 +5881,7 @@
           </p:nvSpPr>
           <p:spPr>
             <a:xfrm>
-              <a:off x="5823509" y="5271609"/>
+              <a:off x="5834254" y="4884826"/>
               <a:ext cx="117404" cy="117404"/>
             </a:xfrm>
             <a:prstGeom prst="ellipse">
@@ -5916,7 +5916,7 @@
           </p:nvSpPr>
           <p:spPr>
             <a:xfrm>
-              <a:off x="6118421" y="5392923"/>
+              <a:off x="6110611" y="5410667"/>
               <a:ext cx="117404" cy="117404"/>
             </a:xfrm>
             <a:prstGeom prst="ellipse">
@@ -5951,7 +5951,7 @@
           </p:nvSpPr>
           <p:spPr>
             <a:xfrm>
-              <a:off x="6380853" y="5465624"/>
+              <a:off x="6393009" y="5054838"/>
               <a:ext cx="117404" cy="117404"/>
             </a:xfrm>
             <a:prstGeom prst="ellipse">
@@ -5986,7 +5986,7 @@
           </p:nvSpPr>
           <p:spPr>
             <a:xfrm>
-              <a:off x="6817222" y="5528557"/>
+              <a:off x="6817810" y="4691260"/>
               <a:ext cx="117404" cy="117404"/>
             </a:xfrm>
             <a:prstGeom prst="ellipse">
@@ -6021,7 +6021,7 @@
           </p:nvSpPr>
           <p:spPr>
             <a:xfrm>
-              <a:off x="7107885" y="4800452"/>
+              <a:off x="7085313" y="5174512"/>
               <a:ext cx="117404" cy="117404"/>
             </a:xfrm>
             <a:prstGeom prst="ellipse">
@@ -6056,7 +6056,7 @@
           </p:nvSpPr>
           <p:spPr>
             <a:xfrm>
-              <a:off x="7507308" y="4986843"/>
+              <a:off x="7501954" y="5583094"/>
               <a:ext cx="117404" cy="117404"/>
             </a:xfrm>
             <a:prstGeom prst="ellipse">
@@ -6545,7 +6545,7 @@
           </p:nvSpPr>
           <p:spPr>
             <a:xfrm>
-              <a:off x="3785734" y="5885280"/>
+              <a:off x="3777065" y="5885280"/>
               <a:ext cx="0" cy="34794"/>
             </a:xfrm>
             <a:custGeom>
@@ -6585,7 +6585,7 @@
           </p:nvSpPr>
           <p:spPr>
             <a:xfrm>
-              <a:off x="5188878" y="5885280"/>
+              <a:off x="5182767" y="5885280"/>
               <a:ext cx="0" cy="34794"/>
             </a:xfrm>
             <a:custGeom>
@@ -6625,7 +6625,7 @@
           </p:nvSpPr>
           <p:spPr>
             <a:xfrm>
-              <a:off x="6592021" y="5885280"/>
+              <a:off x="6588469" y="5885280"/>
               <a:ext cx="0" cy="34794"/>
             </a:xfrm>
             <a:custGeom>
@@ -6665,7 +6665,7 @@
           </p:nvSpPr>
           <p:spPr>
             <a:xfrm>
-              <a:off x="7995165" y="5885280"/>
+              <a:off x="7994172" y="5885280"/>
               <a:ext cx="0" cy="34794"/>
             </a:xfrm>
             <a:custGeom>
@@ -6705,7 +6705,7 @@
           </p:nvSpPr>
           <p:spPr>
             <a:xfrm>
-              <a:off x="3573840" y="5944065"/>
+              <a:off x="3565171" y="5944065"/>
               <a:ext cx="423788" cy="185663"/>
             </a:xfrm>
             <a:prstGeom prst="rect">
@@ -6751,7 +6751,7 @@
           </p:nvSpPr>
           <p:spPr>
             <a:xfrm>
-              <a:off x="4976984" y="5944065"/>
+              <a:off x="4970873" y="5944065"/>
               <a:ext cx="423788" cy="185663"/>
             </a:xfrm>
             <a:prstGeom prst="rect">
@@ -6797,7 +6797,7 @@
           </p:nvSpPr>
           <p:spPr>
             <a:xfrm>
-              <a:off x="6380127" y="5943941"/>
+              <a:off x="6376575" y="5943941"/>
               <a:ext cx="423788" cy="185787"/>
             </a:xfrm>
             <a:prstGeom prst="rect">
@@ -6843,7 +6843,7 @@
           </p:nvSpPr>
           <p:spPr>
             <a:xfrm>
-              <a:off x="7783271" y="5944065"/>
+              <a:off x="7782278" y="5944065"/>
               <a:ext cx="423788" cy="185663"/>
             </a:xfrm>
             <a:prstGeom prst="rect">

</xml_diff>